<commit_message>
fix(guardrails): separate per-IP budget (a room shares one IP); fix evidence and cost labels
- RATE_LIMIT_IP_MAX (200/10 min) distinct from the per-session limit (20/10 min)
- Dated production run evidence (no overwrite); citations updated
- Build cost relabeled as the app's API usage (coding-agent session not included)
- Git tag on each step slide; final verification evidence (links, RLS, branding)

Co-Authored-By: Claude Opus 5.5 <noreply@anthropic.com>
</commit_message>
<xml_diff>
--- a/presentacion/AI_Engineering_Skills_Caso_Practico.pptx
+++ b/presentacion/AI_Engineering_Skills_Caso_Practico.pptx
@@ -12362,6 +12362,41 @@
         </p:nvSpPr>
         <p:spPr>
           <a:xfrm>
+            <a:off x="8961120" y="9226296"/>
+            <a:ext cx="7498079" cy="329184"/>
+          </a:xfrm>
+          <a:prstGeom prst="rect">
+            <a:avLst/>
+          </a:prstGeom>
+          <a:noFill/>
+        </p:spPr>
+        <p:txBody>
+          <a:bodyPr wrap="square" lIns="0" rIns="0" tIns="0" bIns="0" anchor="t">
+            <a:spAutoFit/>
+          </a:bodyPr>
+          <a:lstStyle/>
+          <a:p>
+            <a:pPr algn="r"/>
+            <a:r>
+              <a:rPr sz="1600" b="0">
+                <a:solidFill>
+                  <a:srgbClr val="0283BA"/>
+                </a:solidFill>
+                <a:latin typeface="Courier New"/>
+              </a:rPr>
+              <a:t>paso-02-arquitectura-datos</a:t>
+            </a:r>
+          </a:p>
+        </p:txBody>
+      </p:sp>
+      <p:sp>
+        <p:nvSpPr>
+          <p:cNvPr id="17" name="TextBox 16"/>
+          <p:cNvSpPr txBox="1"/>
+          <p:nvPr/>
+        </p:nvSpPr>
+        <p:spPr>
+          <a:xfrm>
             <a:off x="1143000" y="9226296"/>
             <a:ext cx="8229600" cy="329184"/>
           </a:xfrm>
@@ -12391,7 +12426,7 @@
       </p:sp>
       <p:sp>
         <p:nvSpPr>
-          <p:cNvPr id="17" name="TextBox 16"/>
+          <p:cNvPr id="18" name="TextBox 17"/>
           <p:cNvSpPr txBox="1"/>
           <p:nvPr/>
         </p:nvSpPr>
@@ -12942,6 +12977,41 @@
         </p:nvSpPr>
         <p:spPr>
           <a:xfrm>
+            <a:off x="8961120" y="9226296"/>
+            <a:ext cx="7498079" cy="329184"/>
+          </a:xfrm>
+          <a:prstGeom prst="rect">
+            <a:avLst/>
+          </a:prstGeom>
+          <a:noFill/>
+        </p:spPr>
+        <p:txBody>
+          <a:bodyPr wrap="square" lIns="0" rIns="0" tIns="0" bIns="0" anchor="t">
+            <a:spAutoFit/>
+          </a:bodyPr>
+          <a:lstStyle/>
+          <a:p>
+            <a:pPr algn="r"/>
+            <a:r>
+              <a:rPr sz="1600" b="0">
+                <a:solidFill>
+                  <a:srgbClr val="0283BA"/>
+                </a:solidFill>
+                <a:latin typeface="Courier New"/>
+              </a:rPr>
+              <a:t>paso-03-primer-llm</a:t>
+            </a:r>
+          </a:p>
+        </p:txBody>
+      </p:sp>
+      <p:sp>
+        <p:nvSpPr>
+          <p:cNvPr id="15" name="TextBox 14"/>
+          <p:cNvSpPr txBox="1"/>
+          <p:nvPr/>
+        </p:nvSpPr>
+        <p:spPr>
+          <a:xfrm>
             <a:off x="1143000" y="9226296"/>
             <a:ext cx="8229600" cy="329184"/>
           </a:xfrm>
@@ -12971,7 +13041,7 @@
       </p:sp>
       <p:sp>
         <p:nvSpPr>
-          <p:cNvPr id="15" name="TextBox 14"/>
+          <p:cNvPr id="16" name="TextBox 15"/>
           <p:cNvSpPr txBox="1"/>
           <p:nvPr/>
         </p:nvSpPr>
@@ -13407,6 +13477,41 @@
         </p:nvSpPr>
         <p:spPr>
           <a:xfrm>
+            <a:off x="8961120" y="9226296"/>
+            <a:ext cx="7498079" cy="329184"/>
+          </a:xfrm>
+          <a:prstGeom prst="rect">
+            <a:avLst/>
+          </a:prstGeom>
+          <a:noFill/>
+        </p:spPr>
+        <p:txBody>
+          <a:bodyPr wrap="square" lIns="0" rIns="0" tIns="0" bIns="0" anchor="t">
+            <a:spAutoFit/>
+          </a:bodyPr>
+          <a:lstStyle/>
+          <a:p>
+            <a:pPr algn="r"/>
+            <a:r>
+              <a:rPr sz="1600" b="0">
+                <a:solidFill>
+                  <a:srgbClr val="0283BA"/>
+                </a:solidFill>
+                <a:latin typeface="Courier New"/>
+              </a:rPr>
+              <a:t>paso-04-evals</a:t>
+            </a:r>
+          </a:p>
+        </p:txBody>
+      </p:sp>
+      <p:sp>
+        <p:nvSpPr>
+          <p:cNvPr id="13" name="TextBox 12"/>
+          <p:cNvSpPr txBox="1"/>
+          <p:nvPr/>
+        </p:nvSpPr>
+        <p:spPr>
+          <a:xfrm>
             <a:off x="1143000" y="9226296"/>
             <a:ext cx="8229600" cy="329184"/>
           </a:xfrm>
@@ -13436,7 +13541,7 @@
       </p:sp>
       <p:sp>
         <p:nvSpPr>
-          <p:cNvPr id="13" name="TextBox 12"/>
+          <p:cNvPr id="14" name="TextBox 13"/>
           <p:cNvSpPr txBox="1"/>
           <p:nvPr/>
         </p:nvSpPr>
@@ -14459,6 +14564,41 @@
         </p:nvSpPr>
         <p:spPr>
           <a:xfrm>
+            <a:off x="8961120" y="9226296"/>
+            <a:ext cx="7498079" cy="329184"/>
+          </a:xfrm>
+          <a:prstGeom prst="rect">
+            <a:avLst/>
+          </a:prstGeom>
+          <a:noFill/>
+        </p:spPr>
+        <p:txBody>
+          <a:bodyPr wrap="square" lIns="0" rIns="0" tIns="0" bIns="0" anchor="t">
+            <a:spAutoFit/>
+          </a:bodyPr>
+          <a:lstStyle/>
+          <a:p>
+            <a:pPr algn="r"/>
+            <a:r>
+              <a:rPr sz="1600" b="0">
+                <a:solidFill>
+                  <a:srgbClr val="0283BA"/>
+                </a:solidFill>
+                <a:latin typeface="Courier New"/>
+              </a:rPr>
+              <a:t>paso-05-rag</a:t>
+            </a:r>
+          </a:p>
+        </p:txBody>
+      </p:sp>
+      <p:sp>
+        <p:nvSpPr>
+          <p:cNvPr id="28" name="TextBox 27"/>
+          <p:cNvSpPr txBox="1"/>
+          <p:nvPr/>
+        </p:nvSpPr>
+        <p:spPr>
+          <a:xfrm>
             <a:off x="1143000" y="9226296"/>
             <a:ext cx="8229600" cy="329184"/>
           </a:xfrm>
@@ -14488,7 +14628,7 @@
       </p:sp>
       <p:sp>
         <p:nvSpPr>
-          <p:cNvPr id="28" name="TextBox 27"/>
+          <p:cNvPr id="29" name="TextBox 28"/>
           <p:cNvSpPr txBox="1"/>
           <p:nvPr/>
         </p:nvSpPr>
@@ -14983,6 +15123,41 @@
         </p:nvSpPr>
         <p:spPr>
           <a:xfrm>
+            <a:off x="8961120" y="9226296"/>
+            <a:ext cx="7498079" cy="329184"/>
+          </a:xfrm>
+          <a:prstGeom prst="rect">
+            <a:avLst/>
+          </a:prstGeom>
+          <a:noFill/>
+        </p:spPr>
+        <p:txBody>
+          <a:bodyPr wrap="square" lIns="0" rIns="0" tIns="0" bIns="0" anchor="t">
+            <a:spAutoFit/>
+          </a:bodyPr>
+          <a:lstStyle/>
+          <a:p>
+            <a:pPr algn="r"/>
+            <a:r>
+              <a:rPr sz="1600" b="0">
+                <a:solidFill>
+                  <a:srgbClr val="0283BA"/>
+                </a:solidFill>
+                <a:latin typeface="Courier New"/>
+              </a:rPr>
+              <a:t>paso-06-agente</a:t>
+            </a:r>
+          </a:p>
+        </p:txBody>
+      </p:sp>
+      <p:sp>
+        <p:nvSpPr>
+          <p:cNvPr id="15" name="TextBox 14"/>
+          <p:cNvSpPr txBox="1"/>
+          <p:nvPr/>
+        </p:nvSpPr>
+        <p:spPr>
+          <a:xfrm>
             <a:off x="1143000" y="9226296"/>
             <a:ext cx="8229600" cy="329184"/>
           </a:xfrm>
@@ -15012,7 +15187,7 @@
       </p:sp>
       <p:sp>
         <p:nvSpPr>
-          <p:cNvPr id="15" name="TextBox 14"/>
+          <p:cNvPr id="16" name="TextBox 15"/>
           <p:cNvSpPr txBox="1"/>
           <p:nvPr/>
         </p:nvSpPr>
@@ -15768,6 +15943,41 @@
         </p:nvSpPr>
         <p:spPr>
           <a:xfrm>
+            <a:off x="8961120" y="9226296"/>
+            <a:ext cx="7498079" cy="329184"/>
+          </a:xfrm>
+          <a:prstGeom prst="rect">
+            <a:avLst/>
+          </a:prstGeom>
+          <a:noFill/>
+        </p:spPr>
+        <p:txBody>
+          <a:bodyPr wrap="square" lIns="0" rIns="0" tIns="0" bIns="0" anchor="t">
+            <a:spAutoFit/>
+          </a:bodyPr>
+          <a:lstStyle/>
+          <a:p>
+            <a:pPr algn="r"/>
+            <a:r>
+              <a:rPr sz="1600" b="0">
+                <a:solidFill>
+                  <a:srgbClr val="0283BA"/>
+                </a:solidFill>
+                <a:latin typeface="Courier New"/>
+              </a:rPr>
+              <a:t>paso-06-agente</a:t>
+            </a:r>
+          </a:p>
+        </p:txBody>
+      </p:sp>
+      <p:sp>
+        <p:nvSpPr>
+          <p:cNvPr id="21" name="TextBox 20"/>
+          <p:cNvSpPr txBox="1"/>
+          <p:nvPr/>
+        </p:nvSpPr>
+        <p:spPr>
+          <a:xfrm>
             <a:off x="1143000" y="9226296"/>
             <a:ext cx="8229600" cy="329184"/>
           </a:xfrm>
@@ -15797,7 +16007,7 @@
       </p:sp>
       <p:sp>
         <p:nvSpPr>
-          <p:cNvPr id="21" name="TextBox 20"/>
+          <p:cNvPr id="22" name="TextBox 21"/>
           <p:cNvSpPr txBox="1"/>
           <p:nvPr/>
         </p:nvSpPr>
@@ -16764,6 +16974,41 @@
         </p:nvSpPr>
         <p:spPr>
           <a:xfrm>
+            <a:off x="8961120" y="9226296"/>
+            <a:ext cx="7498079" cy="329184"/>
+          </a:xfrm>
+          <a:prstGeom prst="rect">
+            <a:avLst/>
+          </a:prstGeom>
+          <a:noFill/>
+        </p:spPr>
+        <p:txBody>
+          <a:bodyPr wrap="square" lIns="0" rIns="0" tIns="0" bIns="0" anchor="t">
+            <a:spAutoFit/>
+          </a:bodyPr>
+          <a:lstStyle/>
+          <a:p>
+            <a:pPr algn="r"/>
+            <a:r>
+              <a:rPr sz="1600" b="0">
+                <a:solidFill>
+                  <a:srgbClr val="0283BA"/>
+                </a:solidFill>
+                <a:latin typeface="Courier New"/>
+              </a:rPr>
+              <a:t>paso-07-ml-clasico</a:t>
+            </a:r>
+          </a:p>
+        </p:txBody>
+      </p:sp>
+      <p:sp>
+        <p:nvSpPr>
+          <p:cNvPr id="28" name="TextBox 27"/>
+          <p:cNvSpPr txBox="1"/>
+          <p:nvPr/>
+        </p:nvSpPr>
+        <p:spPr>
+          <a:xfrm>
             <a:off x="1143000" y="9226296"/>
             <a:ext cx="8229600" cy="329184"/>
           </a:xfrm>
@@ -16793,7 +17038,7 @@
       </p:sp>
       <p:sp>
         <p:nvSpPr>
-          <p:cNvPr id="28" name="TextBox 27"/>
+          <p:cNvPr id="29" name="TextBox 28"/>
           <p:cNvSpPr txBox="1"/>
           <p:nvPr/>
         </p:nvSpPr>
@@ -17676,6 +17921,41 @@
         </p:nvSpPr>
         <p:spPr>
           <a:xfrm>
+            <a:off x="8961120" y="9226296"/>
+            <a:ext cx="7498079" cy="329184"/>
+          </a:xfrm>
+          <a:prstGeom prst="rect">
+            <a:avLst/>
+          </a:prstGeom>
+          <a:noFill/>
+        </p:spPr>
+        <p:txBody>
+          <a:bodyPr wrap="square" lIns="0" rIns="0" tIns="0" bIns="0" anchor="t">
+            <a:spAutoFit/>
+          </a:bodyPr>
+          <a:lstStyle/>
+          <a:p>
+            <a:pPr algn="r"/>
+            <a:r>
+              <a:rPr sz="1600" b="0">
+                <a:solidFill>
+                  <a:srgbClr val="0283BA"/>
+                </a:solidFill>
+                <a:latin typeface="Courier New"/>
+              </a:rPr>
+              <a:t>paso-01-entorno-agente  ·  paso-08-producto-completo</a:t>
+            </a:r>
+          </a:p>
+        </p:txBody>
+      </p:sp>
+      <p:sp>
+        <p:nvSpPr>
+          <p:cNvPr id="24" name="TextBox 23"/>
+          <p:cNvSpPr txBox="1"/>
+          <p:nvPr/>
+        </p:nvSpPr>
+        <p:spPr>
+          <a:xfrm>
             <a:off x="1143000" y="9226296"/>
             <a:ext cx="8229600" cy="329184"/>
           </a:xfrm>
@@ -17705,7 +17985,7 @@
       </p:sp>
       <p:sp>
         <p:nvSpPr>
-          <p:cNvPr id="24" name="TextBox 23"/>
+          <p:cNvPr id="25" name="TextBox 24"/>
           <p:cNvSpPr txBox="1"/>
           <p:nvPr/>
         </p:nvSpPr>
@@ -18642,6 +18922,41 @@
         </p:nvSpPr>
         <p:spPr>
           <a:xfrm>
+            <a:off x="8961120" y="9226296"/>
+            <a:ext cx="7498079" cy="329184"/>
+          </a:xfrm>
+          <a:prstGeom prst="rect">
+            <a:avLst/>
+          </a:prstGeom>
+          <a:noFill/>
+        </p:spPr>
+        <p:txBody>
+          <a:bodyPr wrap="square" lIns="0" rIns="0" tIns="0" bIns="0" anchor="t">
+            <a:spAutoFit/>
+          </a:bodyPr>
+          <a:lstStyle/>
+          <a:p>
+            <a:pPr algn="r"/>
+            <a:r>
+              <a:rPr sz="1600" b="0">
+                <a:solidFill>
+                  <a:srgbClr val="0283BA"/>
+                </a:solidFill>
+                <a:latin typeface="Courier New"/>
+              </a:rPr>
+              <a:t>paso-09-produccion</a:t>
+            </a:r>
+          </a:p>
+        </p:txBody>
+      </p:sp>
+      <p:sp>
+        <p:nvSpPr>
+          <p:cNvPr id="26" name="TextBox 25"/>
+          <p:cNvSpPr txBox="1"/>
+          <p:nvPr/>
+        </p:nvSpPr>
+        <p:spPr>
+          <a:xfrm>
             <a:off x="1143000" y="9226296"/>
             <a:ext cx="8229600" cy="329184"/>
           </a:xfrm>
@@ -18671,7 +18986,7 @@
       </p:sp>
       <p:sp>
         <p:nvSpPr>
-          <p:cNvPr id="26" name="TextBox 25"/>
+          <p:cNvPr id="27" name="TextBox 26"/>
           <p:cNvSpPr txBox="1"/>
           <p:nvPr/>
         </p:nvSpPr>

</xml_diff>

<commit_message>
style(deck): distinct hue per pillar on the 11-steps timeline slide
Co-Authored-By: Claude Opus 5.5 <noreply@anthropic.com>
</commit_message>
<xml_diff>
--- a/presentacion/AI_Engineering_Skills_Caso_Practico.pptx
+++ b/presentacion/AI_Engineering_Skills_Caso_Practico.pptx
@@ -10202,7 +10202,7 @@
             <a:avLst/>
           </a:prstGeom>
           <a:solidFill>
-            <a:srgbClr val="7DCEF4"/>
+            <a:srgbClr val="7A4FD0"/>
           </a:solidFill>
           <a:ln>
             <a:noFill/>
@@ -10231,7 +10231,7 @@
             <a:r>
               <a:rPr sz="2400">
                 <a:solidFill>
-                  <a:srgbClr val="1A2850"/>
+                  <a:srgbClr val="FFFFFF"/>
                 </a:solidFill>
                 <a:latin typeface="Arial"/>
               </a:rPr>
@@ -10294,7 +10294,7 @@
             <a:avLst/>
           </a:prstGeom>
           <a:solidFill>
-            <a:srgbClr val="1A2850"/>
+            <a:srgbClr val="E0680B"/>
           </a:solidFill>
           <a:ln>
             <a:noFill/>
@@ -10386,7 +10386,7 @@
             <a:avLst/>
           </a:prstGeom>
           <a:solidFill>
-            <a:srgbClr val="0283BA"/>
+            <a:srgbClr val="1E9E62"/>
           </a:solidFill>
           <a:ln>
             <a:noFill/>
@@ -10478,7 +10478,7 @@
             <a:avLst/>
           </a:prstGeom>
           <a:solidFill>
-            <a:srgbClr val="01A2E9"/>
+            <a:srgbClr val="0283BA"/>
           </a:solidFill>
           <a:ln>
             <a:noFill/>
@@ -10570,7 +10570,7 @@
             <a:avLst/>
           </a:prstGeom>
           <a:solidFill>
-            <a:srgbClr val="01A2E9"/>
+            <a:srgbClr val="0283BA"/>
           </a:solidFill>
           <a:ln>
             <a:noFill/>
@@ -10662,7 +10662,7 @@
             <a:avLst/>
           </a:prstGeom>
           <a:solidFill>
-            <a:srgbClr val="01A2E9"/>
+            <a:srgbClr val="0283BA"/>
           </a:solidFill>
           <a:ln>
             <a:noFill/>
@@ -10754,7 +10754,7 @@
             <a:avLst/>
           </a:prstGeom>
           <a:solidFill>
-            <a:srgbClr val="01A2E9"/>
+            <a:srgbClr val="0283BA"/>
           </a:solidFill>
           <a:ln>
             <a:noFill/>
@@ -10807,7 +10807,7 @@
             <a:avLst/>
           </a:prstGeom>
           <a:solidFill>
-            <a:srgbClr val="0283BA"/>
+            <a:srgbClr val="1E9E62"/>
           </a:solidFill>
           <a:ln w="19050">
             <a:solidFill>
@@ -10892,7 +10892,7 @@
             <a:avLst/>
           </a:prstGeom>
           <a:solidFill>
-            <a:srgbClr val="01A2E9"/>
+            <a:srgbClr val="0283BA"/>
           </a:solidFill>
           <a:ln>
             <a:noFill/>
@@ -10945,7 +10945,7 @@
             <a:avLst/>
           </a:prstGeom>
           <a:solidFill>
-            <a:srgbClr val="7DCEF4"/>
+            <a:srgbClr val="7A4FD0"/>
           </a:solidFill>
           <a:ln w="19050">
             <a:solidFill>
@@ -11030,7 +11030,7 @@
             <a:avLst/>
           </a:prstGeom>
           <a:solidFill>
-            <a:srgbClr val="0283BA"/>
+            <a:srgbClr val="1E9E62"/>
           </a:solidFill>
           <a:ln>
             <a:noFill/>
@@ -11083,7 +11083,7 @@
             <a:avLst/>
           </a:prstGeom>
           <a:solidFill>
-            <a:srgbClr val="1A2850"/>
+            <a:srgbClr val="E0680B"/>
           </a:solidFill>
           <a:ln w="19050">
             <a:solidFill>
@@ -11168,7 +11168,7 @@
             <a:avLst/>
           </a:prstGeom>
           <a:solidFill>
-            <a:srgbClr val="01A2E9"/>
+            <a:srgbClr val="0283BA"/>
           </a:solidFill>
           <a:ln>
             <a:noFill/>
@@ -11221,7 +11221,7 @@
             <a:avLst/>
           </a:prstGeom>
           <a:solidFill>
-            <a:srgbClr val="0283BA"/>
+            <a:srgbClr val="1E9E62"/>
           </a:solidFill>
           <a:ln w="19050">
             <a:solidFill>
@@ -11306,7 +11306,7 @@
             <a:avLst/>
           </a:prstGeom>
           <a:solidFill>
-            <a:srgbClr val="7DCEF4"/>
+            <a:srgbClr val="7A4FD0"/>
           </a:solidFill>
           <a:ln>
             <a:noFill/>
@@ -11335,7 +11335,7 @@
             <a:r>
               <a:rPr sz="2400">
                 <a:solidFill>
-                  <a:srgbClr val="1A2850"/>
+                  <a:srgbClr val="FFFFFF"/>
                 </a:solidFill>
                 <a:latin typeface="Arial"/>
               </a:rPr>
@@ -11398,7 +11398,7 @@
             <a:avLst/>
           </a:prstGeom>
           <a:solidFill>
-            <a:srgbClr val="01A2E9"/>
+            <a:srgbClr val="0283BA"/>
           </a:solidFill>
           <a:ln>
             <a:noFill/>
@@ -11477,7 +11477,7 @@
             <a:avLst/>
           </a:prstGeom>
           <a:solidFill>
-            <a:srgbClr val="0283BA"/>
+            <a:srgbClr val="1E9E62"/>
           </a:solidFill>
           <a:ln>
             <a:noFill/>
@@ -11556,7 +11556,7 @@
             <a:avLst/>
           </a:prstGeom>
           <a:solidFill>
-            <a:srgbClr val="1A2850"/>
+            <a:srgbClr val="E0680B"/>
           </a:solidFill>
           <a:ln>
             <a:noFill/>
@@ -11635,7 +11635,7 @@
             <a:avLst/>
           </a:prstGeom>
           <a:solidFill>
-            <a:srgbClr val="7DCEF4"/>
+            <a:srgbClr val="7A4FD0"/>
           </a:solidFill>
           <a:ln>
             <a:noFill/>

</xml_diff>